<commit_message>
Remove mobile number from SST Course PPTs and regenerate PDFs
</commit_message>
<xml_diff>
--- a/SST_Complete_Course_SagarSir/01_Civics_नागरिक_शास्त्र/Class_01_Civics_Indian_Constitution_Making.pptx
+++ b/SST_Complete_Course_SagarSir/01_Civics_नागरिक_शास्त्र/Class_01_Civics_Indian_Constitution_Making.pptx
@@ -3367,7 +3367,7 @@
               </a:defRPr>
             </a:pPr>
             <a:r>
-              <a:t>मार्गदर्शक: श्रवण कुमार 'सागर' (Sagar Sir)  |  Helpline: +91 91101 13671  |  sagarcoaching.tech</a:t>
+              <a:t>मार्गदर्शक: श्रवण कुमार 'सागर' (Sagar Sir)  |  sagarcoaching.tech</a:t>
             </a:r>
           </a:p>
         </p:txBody>
@@ -3558,7 +3558,7 @@
               </a:defRPr>
             </a:pPr>
             <a:r>
-              <a:t>WhatsApp / Helpline: +91 91101 13671  |  Official Website: sagarcoaching.tech  |  Slide 10 of 37</a:t>
+              <a:t>Official Website: sagarcoaching.tech  |  Slide 10 of 37</a:t>
             </a:r>
           </a:p>
         </p:txBody>
@@ -4092,7 +4092,7 @@
               </a:defRPr>
             </a:pPr>
             <a:r>
-              <a:t>WhatsApp / Helpline: +91 91101 13671  |  Official Website: sagarcoaching.tech  |  Slide 11 of 37</a:t>
+              <a:t>Official Website: sagarcoaching.tech  |  Slide 11 of 37</a:t>
             </a:r>
           </a:p>
         </p:txBody>
@@ -4558,7 +4558,7 @@
               </a:defRPr>
             </a:pPr>
             <a:r>
-              <a:t>WhatsApp / Helpline: +91 91101 13671  |  Official Website: sagarcoaching.tech  |  Slide 12 of 37</a:t>
+              <a:t>Official Website: sagarcoaching.tech  |  Slide 12 of 37</a:t>
             </a:r>
           </a:p>
         </p:txBody>
@@ -5092,7 +5092,7 @@
               </a:defRPr>
             </a:pPr>
             <a:r>
-              <a:t>WhatsApp / Helpline: +91 91101 13671  |  Official Website: sagarcoaching.tech  |  Slide 13 of 37</a:t>
+              <a:t>Official Website: sagarcoaching.tech  |  Slide 13 of 37</a:t>
             </a:r>
           </a:p>
         </p:txBody>
@@ -5558,7 +5558,7 @@
               </a:defRPr>
             </a:pPr>
             <a:r>
-              <a:t>WhatsApp / Helpline: +91 91101 13671  |  Official Website: sagarcoaching.tech  |  Slide 14 of 37</a:t>
+              <a:t>Official Website: sagarcoaching.tech  |  Slide 14 of 37</a:t>
             </a:r>
           </a:p>
         </p:txBody>
@@ -6092,7 +6092,7 @@
               </a:defRPr>
             </a:pPr>
             <a:r>
-              <a:t>WhatsApp / Helpline: +91 91101 13671  |  Official Website: sagarcoaching.tech  |  Slide 15 of 37</a:t>
+              <a:t>Official Website: sagarcoaching.tech  |  Slide 15 of 37</a:t>
             </a:r>
           </a:p>
         </p:txBody>
@@ -6558,7 +6558,7 @@
               </a:defRPr>
             </a:pPr>
             <a:r>
-              <a:t>WhatsApp / Helpline: +91 91101 13671  |  Official Website: sagarcoaching.tech  |  Slide 16 of 37</a:t>
+              <a:t>Official Website: sagarcoaching.tech  |  Slide 16 of 37</a:t>
             </a:r>
           </a:p>
         </p:txBody>
@@ -7092,7 +7092,7 @@
               </a:defRPr>
             </a:pPr>
             <a:r>
-              <a:t>WhatsApp / Helpline: +91 91101 13671  |  Official Website: sagarcoaching.tech  |  Slide 17 of 37</a:t>
+              <a:t>Official Website: sagarcoaching.tech  |  Slide 17 of 37</a:t>
             </a:r>
           </a:p>
         </p:txBody>
@@ -7558,7 +7558,7 @@
               </a:defRPr>
             </a:pPr>
             <a:r>
-              <a:t>WhatsApp / Helpline: +91 91101 13671  |  Official Website: sagarcoaching.tech  |  Slide 18 of 37</a:t>
+              <a:t>Official Website: sagarcoaching.tech  |  Slide 18 of 37</a:t>
             </a:r>
           </a:p>
         </p:txBody>
@@ -8092,7 +8092,7 @@
               </a:defRPr>
             </a:pPr>
             <a:r>
-              <a:t>WhatsApp / Helpline: +91 91101 13671  |  Official Website: sagarcoaching.tech  |  Slide 19 of 37</a:t>
+              <a:t>Official Website: sagarcoaching.tech  |  Slide 19 of 37</a:t>
             </a:r>
           </a:p>
         </p:txBody>
@@ -8558,7 +8558,7 @@
               </a:defRPr>
             </a:pPr>
             <a:r>
-              <a:t>WhatsApp / Helpline: +91 91101 13671  |  Official Website: sagarcoaching.tech  |  Slide 2 of 37</a:t>
+              <a:t>Official Website: sagarcoaching.tech  |  Slide 2 of 37</a:t>
             </a:r>
           </a:p>
         </p:txBody>
@@ -8956,7 +8956,7 @@
               </a:defRPr>
             </a:pPr>
             <a:r>
-              <a:t>WhatsApp / Helpline: +91 91101 13671  |  Official Website: sagarcoaching.tech  |  Slide 20 of 37</a:t>
+              <a:t>Official Website: sagarcoaching.tech  |  Slide 20 of 37</a:t>
             </a:r>
           </a:p>
         </p:txBody>
@@ -9490,7 +9490,7 @@
               </a:defRPr>
             </a:pPr>
             <a:r>
-              <a:t>WhatsApp / Helpline: +91 91101 13671  |  Official Website: sagarcoaching.tech  |  Slide 21 of 37</a:t>
+              <a:t>Official Website: sagarcoaching.tech  |  Slide 21 of 37</a:t>
             </a:r>
           </a:p>
         </p:txBody>
@@ -9956,7 +9956,7 @@
               </a:defRPr>
             </a:pPr>
             <a:r>
-              <a:t>WhatsApp / Helpline: +91 91101 13671  |  Official Website: sagarcoaching.tech  |  Slide 22 of 37</a:t>
+              <a:t>Official Website: sagarcoaching.tech  |  Slide 22 of 37</a:t>
             </a:r>
           </a:p>
         </p:txBody>
@@ -10490,7 +10490,7 @@
               </a:defRPr>
             </a:pPr>
             <a:r>
-              <a:t>WhatsApp / Helpline: +91 91101 13671  |  Official Website: sagarcoaching.tech  |  Slide 23 of 37</a:t>
+              <a:t>Official Website: sagarcoaching.tech  |  Slide 23 of 37</a:t>
             </a:r>
           </a:p>
         </p:txBody>
@@ -10956,7 +10956,7 @@
               </a:defRPr>
             </a:pPr>
             <a:r>
-              <a:t>WhatsApp / Helpline: +91 91101 13671  |  Official Website: sagarcoaching.tech  |  Slide 24 of 37</a:t>
+              <a:t>Official Website: sagarcoaching.tech  |  Slide 24 of 37</a:t>
             </a:r>
           </a:p>
         </p:txBody>
@@ -11490,7 +11490,7 @@
               </a:defRPr>
             </a:pPr>
             <a:r>
-              <a:t>WhatsApp / Helpline: +91 91101 13671  |  Official Website: sagarcoaching.tech  |  Slide 25 of 37</a:t>
+              <a:t>Official Website: sagarcoaching.tech  |  Slide 25 of 37</a:t>
             </a:r>
           </a:p>
         </p:txBody>
@@ -11956,7 +11956,7 @@
               </a:defRPr>
             </a:pPr>
             <a:r>
-              <a:t>WhatsApp / Helpline: +91 91101 13671  |  Official Website: sagarcoaching.tech  |  Slide 26 of 37</a:t>
+              <a:t>Official Website: sagarcoaching.tech  |  Slide 26 of 37</a:t>
             </a:r>
           </a:p>
         </p:txBody>
@@ -12490,7 +12490,7 @@
               </a:defRPr>
             </a:pPr>
             <a:r>
-              <a:t>WhatsApp / Helpline: +91 91101 13671  |  Official Website: sagarcoaching.tech  |  Slide 27 of 37</a:t>
+              <a:t>Official Website: sagarcoaching.tech  |  Slide 27 of 37</a:t>
             </a:r>
           </a:p>
         </p:txBody>
@@ -12956,7 +12956,7 @@
               </a:defRPr>
             </a:pPr>
             <a:r>
-              <a:t>WhatsApp / Helpline: +91 91101 13671  |  Official Website: sagarcoaching.tech  |  Slide 28 of 37</a:t>
+              <a:t>Official Website: sagarcoaching.tech  |  Slide 28 of 37</a:t>
             </a:r>
           </a:p>
         </p:txBody>
@@ -13490,7 +13490,7 @@
               </a:defRPr>
             </a:pPr>
             <a:r>
-              <a:t>WhatsApp / Helpline: +91 91101 13671  |  Official Website: sagarcoaching.tech  |  Slide 29 of 37</a:t>
+              <a:t>Official Website: sagarcoaching.tech  |  Slide 29 of 37</a:t>
             </a:r>
           </a:p>
         </p:txBody>
@@ -13956,7 +13956,7 @@
               </a:defRPr>
             </a:pPr>
             <a:r>
-              <a:t>WhatsApp / Helpline: +91 91101 13671  |  Official Website: sagarcoaching.tech  |  Slide 3 of 37</a:t>
+              <a:t>Official Website: sagarcoaching.tech  |  Slide 3 of 37</a:t>
             </a:r>
           </a:p>
         </p:txBody>
@@ -14335,7 +14335,7 @@
               </a:defRPr>
             </a:pPr>
             <a:r>
-              <a:t>WhatsApp / Helpline: +91 91101 13671  |  Official Website: sagarcoaching.tech  |  Slide 30 of 37</a:t>
+              <a:t>Official Website: sagarcoaching.tech  |  Slide 30 of 37</a:t>
             </a:r>
           </a:p>
         </p:txBody>
@@ -14869,7 +14869,7 @@
               </a:defRPr>
             </a:pPr>
             <a:r>
-              <a:t>WhatsApp / Helpline: +91 91101 13671  |  Official Website: sagarcoaching.tech  |  Slide 31 of 37</a:t>
+              <a:t>Official Website: sagarcoaching.tech  |  Slide 31 of 37</a:t>
             </a:r>
           </a:p>
         </p:txBody>
@@ -15335,7 +15335,7 @@
               </a:defRPr>
             </a:pPr>
             <a:r>
-              <a:t>WhatsApp / Helpline: +91 91101 13671  |  Official Website: sagarcoaching.tech  |  Slide 32 of 37</a:t>
+              <a:t>Official Website: sagarcoaching.tech  |  Slide 32 of 37</a:t>
             </a:r>
           </a:p>
         </p:txBody>
@@ -15869,7 +15869,7 @@
               </a:defRPr>
             </a:pPr>
             <a:r>
-              <a:t>WhatsApp / Helpline: +91 91101 13671  |  Official Website: sagarcoaching.tech  |  Slide 33 of 37</a:t>
+              <a:t>Official Website: sagarcoaching.tech  |  Slide 33 of 37</a:t>
             </a:r>
           </a:p>
         </p:txBody>
@@ -16335,7 +16335,7 @@
               </a:defRPr>
             </a:pPr>
             <a:r>
-              <a:t>WhatsApp / Helpline: +91 91101 13671  |  Official Website: sagarcoaching.tech  |  Slide 34 of 37</a:t>
+              <a:t>Official Website: sagarcoaching.tech  |  Slide 34 of 37</a:t>
             </a:r>
           </a:p>
         </p:txBody>
@@ -16869,7 +16869,7 @@
               </a:defRPr>
             </a:pPr>
             <a:r>
-              <a:t>WhatsApp / Helpline: +91 91101 13671  |  Official Website: sagarcoaching.tech  |  Slide 35 of 37</a:t>
+              <a:t>Official Website: sagarcoaching.tech  |  Slide 35 of 37</a:t>
             </a:r>
           </a:p>
         </p:txBody>
@@ -17195,7 +17195,7 @@
               </a:defRPr>
             </a:pPr>
             <a:r>
-              <a:t>WhatsApp / Helpline: +91 91101 13671  |  Official Website: sagarcoaching.tech  |  Slide 36 of 37</a:t>
+              <a:t>Official Website: sagarcoaching.tech  |  Slide 36 of 37</a:t>
             </a:r>
           </a:p>
         </p:txBody>
@@ -17492,7 +17492,7 @@
               </a:defRPr>
             </a:pPr>
             <a:r>
-              <a:t>इस क्लास की PDF डाउनलोड करें: sagarcoaching.tech | Helpline: +91 91101 13671</a:t>
+              <a:t>इस क्लास की PDF डाउनलोड करें: sagarcoaching.tech</a:t>
             </a:r>
           </a:p>
         </p:txBody>
@@ -17596,7 +17596,7 @@
               </a:defRPr>
             </a:pPr>
             <a:r>
-              <a:t>मार्गदर्शक: श्रवण कुमार 'सागर' (Sagar Sir)  |  Helpline: +91 91101 13671  |  sagarcoaching.tech</a:t>
+              <a:t>मार्गदर्शक: श्रवण कुमार 'सागर' (Sagar Sir)  |  sagarcoaching.tech</a:t>
             </a:r>
           </a:p>
         </p:txBody>
@@ -17787,7 +17787,7 @@
               </a:defRPr>
             </a:pPr>
             <a:r>
-              <a:t>WhatsApp / Helpline: +91 91101 13671  |  Official Website: sagarcoaching.tech  |  Slide 4 of 37</a:t>
+              <a:t>Official Website: sagarcoaching.tech  |  Slide 4 of 37</a:t>
             </a:r>
           </a:p>
         </p:txBody>
@@ -18166,7 +18166,7 @@
               </a:defRPr>
             </a:pPr>
             <a:r>
-              <a:t>WhatsApp / Helpline: +91 91101 13671  |  Official Website: sagarcoaching.tech  |  Slide 5 of 37</a:t>
+              <a:t>Official Website: sagarcoaching.tech  |  Slide 5 of 37</a:t>
             </a:r>
           </a:p>
         </p:txBody>
@@ -18632,7 +18632,7 @@
               </a:defRPr>
             </a:pPr>
             <a:r>
-              <a:t>WhatsApp / Helpline: +91 91101 13671  |  Official Website: sagarcoaching.tech  |  Slide 6 of 37</a:t>
+              <a:t>Official Website: sagarcoaching.tech  |  Slide 6 of 37</a:t>
             </a:r>
           </a:p>
         </p:txBody>
@@ -19166,7 +19166,7 @@
               </a:defRPr>
             </a:pPr>
             <a:r>
-              <a:t>WhatsApp / Helpline: +91 91101 13671  |  Official Website: sagarcoaching.tech  |  Slide 7 of 37</a:t>
+              <a:t>Official Website: sagarcoaching.tech  |  Slide 7 of 37</a:t>
             </a:r>
           </a:p>
         </p:txBody>
@@ -19632,7 +19632,7 @@
               </a:defRPr>
             </a:pPr>
             <a:r>
-              <a:t>WhatsApp / Helpline: +91 91101 13671  |  Official Website: sagarcoaching.tech  |  Slide 8 of 37</a:t>
+              <a:t>Official Website: sagarcoaching.tech  |  Slide 8 of 37</a:t>
             </a:r>
           </a:p>
         </p:txBody>
@@ -20166,7 +20166,7 @@
               </a:defRPr>
             </a:pPr>
             <a:r>
-              <a:t>WhatsApp / Helpline: +91 91101 13671  |  Official Website: sagarcoaching.tech  |  Slide 9 of 37</a:t>
+              <a:t>Official Website: sagarcoaching.tech  |  Slide 9 of 37</a:t>
             </a:r>
           </a:p>
         </p:txBody>

</xml_diff>